<commit_message>
Migrate project text to English and refresh war room UI
</commit_message>
<xml_diff>
--- a/docs/report/socagent_progress_report.pptx
+++ b/docs/report/socagent_progress_report.pptx
@@ -123,12 +123,12 @@
           <a:lstStyle/>
           <a:p>
             <a:r>
-              <a:rPr lang="zh-CN" sz="2600" b="1" dirty="0" smtClean="0">
-                <a:solidFill>
-                  <a:srgbClr val="0F172A"/>
-                </a:solidFill>
-              </a:rPr>
-              <a:t>导师汇报</a:t>
+              <a:rPr lang="en-US" sz="2600" b="1" dirty="0" smtClean="0">
+                <a:solidFill>
+                  <a:srgbClr val="0F172A"/>
+                </a:solidFill>
+              </a:rPr>
+              <a:t>Advisor Report</a:t>
             </a:r>
           </a:p>
         </p:txBody>
@@ -157,7 +157,7 @@
           <a:lstStyle/>
           <a:p>
             <a:r>
-              <a:rPr lang="zh-CN" sz="3000" b="1" dirty="0" smtClean="0">
+              <a:rPr lang="en-US" sz="3000" b="1" dirty="0" smtClean="0">
                 <a:solidFill>
                   <a:srgbClr val="0F172A"/>
                 </a:solidFill>
@@ -167,12 +167,12 @@
           </a:p>
           <a:p>
             <a:r>
-              <a:rPr lang="zh-CN" sz="3000" b="1" dirty="0" smtClean="0">
-                <a:solidFill>
-                  <a:srgbClr val="0F172A"/>
-                </a:solidFill>
-              </a:rPr>
-              <a:t>阶段性进展汇报</a:t>
+              <a:rPr lang="en-US" sz="3000" b="1" dirty="0" smtClean="0">
+                <a:solidFill>
+                  <a:srgbClr val="0F172A"/>
+                </a:solidFill>
+              </a:rPr>
+              <a:t>Progress Report</a:t>
             </a:r>
           </a:p>
         </p:txBody>
@@ -201,22 +201,22 @@
           <a:lstStyle/>
           <a:p>
             <a:r>
-              <a:rPr lang="zh-CN" sz="1800" b="0" dirty="0" smtClean="0">
+              <a:rPr lang="en-US" sz="1700" b="0" dirty="0" smtClean="0">
                 <a:solidFill>
                   <a:srgbClr val="475569"/>
                 </a:solidFill>
               </a:rPr>
-              <a:t>面向安全告警溯源场景的三角色多智能体原型</a:t>
-            </a:r>
-          </a:p>
-          <a:p>
-            <a:r>
-              <a:rPr lang="zh-CN" sz="1800" b="0" dirty="0" smtClean="0">
+              <a:t>A three-role multi-agent prototype for security alert traceback</a:t>
+            </a:r>
+          </a:p>
+          <a:p>
+            <a:r>
+              <a:rPr lang="en-US" sz="1700" b="0" dirty="0" smtClean="0">
                 <a:solidFill>
                   <a:srgbClr val="475569"/>
                 </a:solidFill>
               </a:rPr>
-              <a:t>当前重点：打通 workflow、在开源数据集上持续验证与调优</a:t>
+              <a:t>Current focus: run the workflow end to end and keep validating and tuning on open datasets</a:t>
             </a:r>
           </a:p>
         </p:txBody>
@@ -247,7 +247,7 @@
           <a:lstStyle/>
           <a:p>
             <a:r>
-              <a:rPr lang="zh-CN" sz="1800" b="1" dirty="0" smtClean="0">
+              <a:rPr lang="en-US" sz="1700" b="1" dirty="0" smtClean="0">
                 <a:solidFill>
                   <a:srgbClr val="FFFFFF"/>
                 </a:solidFill>
@@ -257,12 +257,12 @@
           </a:p>
           <a:p>
             <a:r>
-              <a:rPr lang="zh-CN" sz="1800" b="1" dirty="0" smtClean="0">
+              <a:rPr lang="en-US" sz="1700" b="1" dirty="0" smtClean="0">
                 <a:solidFill>
                   <a:srgbClr val="FFFFFF"/>
                 </a:solidFill>
               </a:rPr>
-              <a:t>任务规划</a:t>
+              <a:t>Task Planning</a:t>
             </a:r>
           </a:p>
         </p:txBody>
@@ -293,7 +293,7 @@
           <a:lstStyle/>
           <a:p>
             <a:r>
-              <a:rPr lang="zh-CN" sz="1800" b="1" dirty="0" smtClean="0">
+              <a:rPr lang="en-US" sz="1700" b="1" dirty="0" smtClean="0">
                 <a:solidFill>
                   <a:srgbClr val="FFFFFF"/>
                 </a:solidFill>
@@ -303,12 +303,12 @@
           </a:p>
           <a:p>
             <a:r>
-              <a:rPr lang="zh-CN" sz="1800" b="1" dirty="0" smtClean="0">
+              <a:rPr lang="en-US" sz="1700" b="1" dirty="0" smtClean="0">
                 <a:solidFill>
                   <a:srgbClr val="FFFFFF"/>
                 </a:solidFill>
               </a:rPr>
-              <a:t>执行检索</a:t>
+              <a:t>Tool Execution</a:t>
             </a:r>
           </a:p>
         </p:txBody>
@@ -339,7 +339,7 @@
           <a:lstStyle/>
           <a:p>
             <a:r>
-              <a:rPr lang="zh-CN" sz="1500" b="1" dirty="0" smtClean="0">
+              <a:rPr lang="en-US" sz="1400" b="1" dirty="0" smtClean="0">
                 <a:solidFill>
                   <a:srgbClr val="FFFFFF"/>
                 </a:solidFill>
@@ -349,12 +349,12 @@
           </a:p>
           <a:p>
             <a:r>
-              <a:rPr lang="zh-CN" sz="1500" b="1" dirty="0" smtClean="0">
+              <a:rPr lang="en-US" sz="1400" b="1" dirty="0" smtClean="0">
                 <a:solidFill>
                   <a:srgbClr val="FFFFFF"/>
                 </a:solidFill>
               </a:rPr>
-              <a:t>复盘</a:t>
+              <a:t>Review</a:t>
             </a:r>
           </a:p>
         </p:txBody>
@@ -387,7 +387,7 @@
           <a:lstStyle/>
           <a:p>
             <a:r>
-              <a:rPr lang="zh-CN" sz="1700" b="1" dirty="0" smtClean="0">
+              <a:rPr lang="en-US" sz="1700" b="1" dirty="0" smtClean="0">
                 <a:solidFill>
                   <a:srgbClr val="0F172A"/>
                 </a:solidFill>
@@ -397,7 +397,7 @@
           </a:p>
           <a:p>
             <a:r>
-              <a:rPr lang="zh-CN" sz="1700" b="1" dirty="0" smtClean="0">
+              <a:rPr lang="en-US" sz="1700" b="1" dirty="0" smtClean="0">
                 <a:solidFill>
                   <a:srgbClr val="0F172A"/>
                 </a:solidFill>
@@ -407,7 +407,7 @@
           </a:p>
           <a:p>
             <a:r>
-              <a:rPr lang="zh-CN" sz="1700" b="1" dirty="0" smtClean="0">
+              <a:rPr lang="en-US" sz="1700" b="1" dirty="0" smtClean="0">
                 <a:solidFill>
                   <a:srgbClr val="0F172A"/>
                 </a:solidFill>
@@ -417,7 +417,7 @@
           </a:p>
           <a:p>
             <a:r>
-              <a:rPr lang="zh-CN" sz="1700" b="1" dirty="0" smtClean="0">
+              <a:rPr lang="en-US" sz="1700" b="1" dirty="0" smtClean="0">
                 <a:solidFill>
                   <a:srgbClr val="0F172A"/>
                 </a:solidFill>
@@ -427,7 +427,7 @@
           </a:p>
           <a:p>
             <a:r>
-              <a:rPr lang="zh-CN" sz="1700" b="1" dirty="0" smtClean="0">
+              <a:rPr lang="en-US" sz="1700" b="1" dirty="0" smtClean="0">
                 <a:solidFill>
                   <a:srgbClr val="0F172A"/>
                 </a:solidFill>
@@ -437,7 +437,7 @@
           </a:p>
           <a:p>
             <a:r>
-              <a:rPr lang="zh-CN" sz="1700" b="1" dirty="0" smtClean="0">
+              <a:rPr lang="en-US" sz="1700" b="1" dirty="0" smtClean="0">
                 <a:solidFill>
                   <a:srgbClr val="0F172A"/>
                 </a:solidFill>
@@ -447,7 +447,7 @@
           </a:p>
           <a:p>
             <a:r>
-              <a:rPr lang="zh-CN" sz="1700" b="1" dirty="0" smtClean="0">
+              <a:rPr lang="en-US" sz="1700" b="1" dirty="0" smtClean="0">
                 <a:solidFill>
                   <a:srgbClr val="0F172A"/>
                 </a:solidFill>
@@ -457,7 +457,7 @@
           </a:p>
           <a:p>
             <a:r>
-              <a:rPr lang="zh-CN" sz="1700" b="1" dirty="0" smtClean="0">
+              <a:rPr lang="en-US" sz="1700" b="1" dirty="0" smtClean="0">
                 <a:solidFill>
                   <a:srgbClr val="0F172A"/>
                 </a:solidFill>
@@ -467,7 +467,7 @@
           </a:p>
           <a:p>
             <a:r>
-              <a:rPr lang="zh-CN" sz="1700" b="1" dirty="0" smtClean="0">
+              <a:rPr lang="en-US" sz="1700" b="1" dirty="0" smtClean="0">
                 <a:solidFill>
                   <a:srgbClr val="0F172A"/>
                 </a:solidFill>
@@ -501,12 +501,12 @@
           <a:lstStyle/>
           <a:p>
             <a:r>
-              <a:rPr lang="zh-CN" sz="1200" b="0" dirty="0" smtClean="0">
+              <a:rPr lang="en-US" sz="1200" b="0" dirty="0" smtClean="0">
                 <a:solidFill>
                   <a:srgbClr val="64748B"/>
                 </a:solidFill>
               </a:rPr>
-              <a:t>生成时间：2026-06-08</a:t>
+              <a:t>Generated: 2026-06-08</a:t>
             </a:r>
           </a:p>
         </p:txBody>
@@ -568,12 +568,12 @@
           <a:lstStyle/>
           <a:p>
             <a:r>
-              <a:rPr lang="zh-CN" sz="2600" b="1" dirty="0" smtClean="0">
-                <a:solidFill>
-                  <a:srgbClr val="0F172A"/>
-                </a:solidFill>
-              </a:rPr>
-              <a:t>1. 当前整体进展</a:t>
+              <a:rPr lang="en-US" sz="2600" b="1" dirty="0" smtClean="0">
+                <a:solidFill>
+                  <a:srgbClr val="0F172A"/>
+                </a:solidFill>
+              </a:rPr>
+              <a:t>1. Overall Progress</a:t>
             </a:r>
           </a:p>
         </p:txBody>
@@ -606,52 +606,52 @@
           <a:lstStyle/>
           <a:p>
             <a:r>
-              <a:rPr lang="zh-CN" sz="1750" b="0" dirty="0" smtClean="0">
-                <a:solidFill>
-                  <a:srgbClr val="0F172A"/>
-                </a:solidFill>
-              </a:rPr>
-              <a:t>1. 已打通多角色闭环 workflow</a:t>
-            </a:r>
-          </a:p>
-          <a:p>
-            <a:r>
-              <a:rPr lang="zh-CN" sz="1750" b="0" dirty="0" smtClean="0">
-                <a:solidFill>
-                  <a:srgbClr val="0F172A"/>
-                </a:solidFill>
-              </a:rPr>
-              <a:t>• Planner 生成 TTT（Traceback Task Tree）</a:t>
-            </a:r>
-          </a:p>
-          <a:p>
-            <a:r>
-              <a:rPr lang="zh-CN" sz="1750" b="0" dirty="0" smtClean="0">
-                <a:solidFill>
-                  <a:srgbClr val="0F172A"/>
-                </a:solidFill>
-              </a:rPr>
-              <a:t>• Executor 领取 L3 叶子节点并执行</a:t>
-            </a:r>
-          </a:p>
-          <a:p>
-            <a:r>
-              <a:rPr lang="zh-CN" sz="1750" b="0" dirty="0" smtClean="0">
-                <a:solidFill>
-                  <a:srgbClr val="0F172A"/>
-                </a:solidFill>
-              </a:rPr>
-              <a:t>• Reviewer 生成 RoundReview，并驱动下一轮 replanning</a:t>
-            </a:r>
-          </a:p>
-          <a:p>
-            <a:r>
-              <a:rPr lang="zh-CN" sz="1750" b="0" dirty="0" smtClean="0">
-                <a:solidFill>
-                  <a:srgbClr val="0F172A"/>
-                </a:solidFill>
-              </a:rPr>
-              <a:t>• 核心链路已形成 Event -&gt; TTT -&gt; Execution -&gt; RoundReview -&gt; TTT</a:t>
+              <a:rPr lang="en-US" sz="1700" b="0" dirty="0" smtClean="0">
+                <a:solidFill>
+                  <a:srgbClr val="0F172A"/>
+                </a:solidFill>
+              </a:rPr>
+              <a:t>1. Multi-role closed-loop workflow is connected</a:t>
+            </a:r>
+          </a:p>
+          <a:p>
+            <a:r>
+              <a:rPr lang="en-US" sz="1700" b="0" dirty="0" smtClean="0">
+                <a:solidFill>
+                  <a:srgbClr val="0F172A"/>
+                </a:solidFill>
+              </a:rPr>
+              <a:t>• Planner builds the TTT (Traceback Task Tree)</a:t>
+            </a:r>
+          </a:p>
+          <a:p>
+            <a:r>
+              <a:rPr lang="en-US" sz="1700" b="0" dirty="0" smtClean="0">
+                <a:solidFill>
+                  <a:srgbClr val="0F172A"/>
+                </a:solidFill>
+              </a:rPr>
+              <a:t>• Executor claims and executes L3 leaf nodes</a:t>
+            </a:r>
+          </a:p>
+          <a:p>
+            <a:r>
+              <a:rPr lang="en-US" sz="1700" b="0" dirty="0" smtClean="0">
+                <a:solidFill>
+                  <a:srgbClr val="0F172A"/>
+                </a:solidFill>
+              </a:rPr>
+              <a:t>• Reviewer produces RoundReview and drives replanning</a:t>
+            </a:r>
+          </a:p>
+          <a:p>
+            <a:r>
+              <a:rPr lang="en-US" sz="1700" b="0" dirty="0" smtClean="0">
+                <a:solidFill>
+                  <a:srgbClr val="0F172A"/>
+                </a:solidFill>
+              </a:rPr>
+              <a:t>• Core chain: Event -&gt; TTT -&gt; Execution -&gt; RoundReview -&gt; TTT</a:t>
             </a:r>
           </a:p>
         </p:txBody>
@@ -684,42 +684,42 @@
           <a:lstStyle/>
           <a:p>
             <a:r>
-              <a:rPr lang="zh-CN" sz="1750" b="0" dirty="0" smtClean="0">
-                <a:solidFill>
-                  <a:srgbClr val="0F172A"/>
-                </a:solidFill>
-              </a:rPr>
-              <a:t>2. 当前验证方式</a:t>
-            </a:r>
-          </a:p>
-          <a:p>
-            <a:r>
-              <a:rPr lang="zh-CN" sz="1750" b="0" dirty="0" smtClean="0">
-                <a:solidFill>
-                  <a:srgbClr val="0F172A"/>
-                </a:solidFill>
-              </a:rPr>
-              <a:t>• 基于 SQLite 共享状态，支持多进程协同</a:t>
-            </a:r>
-          </a:p>
-          <a:p>
-            <a:r>
-              <a:rPr lang="zh-CN" sz="1750" b="0" dirty="0" smtClean="0">
-                <a:solidFill>
-                  <a:srgbClr val="0F172A"/>
-                </a:solidFill>
-              </a:rPr>
-              <a:t>• 通过 Web 首页创建事件，在 war room 观察实时推进</a:t>
-            </a:r>
-          </a:p>
-          <a:p>
-            <a:r>
-              <a:rPr lang="zh-CN" sz="1750" b="0" dirty="0" smtClean="0">
-                <a:solidFill>
-                  <a:srgbClr val="0F172A"/>
-                </a:solidFill>
-              </a:rPr>
-              <a:t>• 已有多轮闭环烟雾测试脚本，可持续验证整体链路</a:t>
+              <a:rPr lang="en-US" sz="1700" b="0" dirty="0" smtClean="0">
+                <a:solidFill>
+                  <a:srgbClr val="0F172A"/>
+                </a:solidFill>
+              </a:rPr>
+              <a:t>2. Current validation approach</a:t>
+            </a:r>
+          </a:p>
+          <a:p>
+            <a:r>
+              <a:rPr lang="en-US" sz="1700" b="0" dirty="0" smtClean="0">
+                <a:solidFill>
+                  <a:srgbClr val="0F172A"/>
+                </a:solidFill>
+              </a:rPr>
+              <a:t>• Shared state through SQLite for multi-process collaboration</a:t>
+            </a:r>
+          </a:p>
+          <a:p>
+            <a:r>
+              <a:rPr lang="en-US" sz="1700" b="0" dirty="0" smtClean="0">
+                <a:solidFill>
+                  <a:srgbClr val="0F172A"/>
+                </a:solidFill>
+              </a:rPr>
+              <a:t>• Create events from the Web home page and observe progress in the war room</a:t>
+            </a:r>
+          </a:p>
+          <a:p>
+            <a:r>
+              <a:rPr lang="en-US" sz="1700" b="0" dirty="0" smtClean="0">
+                <a:solidFill>
+                  <a:srgbClr val="0F172A"/>
+                </a:solidFill>
+              </a:rPr>
+              <a:t>• Multi-round smoke tests are available for end-to-end validation</a:t>
             </a:r>
           </a:p>
         </p:txBody>
@@ -752,42 +752,42 @@
           <a:lstStyle/>
           <a:p>
             <a:r>
-              <a:rPr lang="zh-CN" sz="1750" b="0" dirty="0" smtClean="0">
-                <a:solidFill>
-                  <a:srgbClr val="0F172A"/>
-                </a:solidFill>
-              </a:rPr>
-              <a:t>3. 当前阶段重点</a:t>
-            </a:r>
-          </a:p>
-          <a:p>
-            <a:r>
-              <a:rPr lang="zh-CN" sz="1750" b="0" dirty="0" smtClean="0">
-                <a:solidFill>
-                  <a:srgbClr val="0F172A"/>
-                </a:solidFill>
-              </a:rPr>
-              <a:t>• 在开源 BOTS 数据集上反复测试查询效果与任务拆解质量</a:t>
-            </a:r>
-          </a:p>
-          <a:p>
-            <a:r>
-              <a:rPr lang="zh-CN" sz="1750" b="0" dirty="0" smtClean="0">
-                <a:solidFill>
-                  <a:srgbClr val="0F172A"/>
-                </a:solidFill>
-              </a:rPr>
-              <a:t>• 针对 TTT 构建、工具路由、Splunk 查询意图翻译持续调优</a:t>
-            </a:r>
-          </a:p>
-          <a:p>
-            <a:r>
-              <a:rPr lang="zh-CN" sz="1750" b="0" dirty="0" smtClean="0">
-                <a:solidFill>
-                  <a:srgbClr val="0F172A"/>
-                </a:solidFill>
-              </a:rPr>
-              <a:t>• 让前端展示的状态、消息流、执行记录与真实 SQLite 状态保持一致</a:t>
+              <a:rPr lang="en-US" sz="1700" b="0" dirty="0" smtClean="0">
+                <a:solidFill>
+                  <a:srgbClr val="0F172A"/>
+                </a:solidFill>
+              </a:rPr>
+              <a:t>3. Current focus</a:t>
+            </a:r>
+          </a:p>
+          <a:p>
+            <a:r>
+              <a:rPr lang="en-US" sz="1700" b="0" dirty="0" smtClean="0">
+                <a:solidFill>
+                  <a:srgbClr val="0F172A"/>
+                </a:solidFill>
+              </a:rPr>
+              <a:t>• Repeatedly test query quality and task decomposition on the open BOTS dataset</a:t>
+            </a:r>
+          </a:p>
+          <a:p>
+            <a:r>
+              <a:rPr lang="en-US" sz="1700" b="0" dirty="0" smtClean="0">
+                <a:solidFill>
+                  <a:srgbClr val="0F172A"/>
+                </a:solidFill>
+              </a:rPr>
+              <a:t>• Keep tuning TTT construction, tool routing, and Splunk intent translation</a:t>
+            </a:r>
+          </a:p>
+          <a:p>
+            <a:r>
+              <a:rPr lang="en-US" sz="1700" b="0" dirty="0" smtClean="0">
+                <a:solidFill>
+                  <a:srgbClr val="0F172A"/>
+                </a:solidFill>
+              </a:rPr>
+              <a:t>• Keep front-end status, message flow, and executions aligned with real SQLite state</a:t>
             </a:r>
           </a:p>
         </p:txBody>
@@ -870,12 +870,12 @@
           <a:lstStyle/>
           <a:p>
             <a:r>
-              <a:rPr lang="zh-CN" sz="2600" b="1" dirty="0" smtClean="0">
-                <a:solidFill>
-                  <a:srgbClr val="0F172A"/>
-                </a:solidFill>
-              </a:rPr>
-              <a:t>2. BOTS 数据集介绍</a:t>
+              <a:rPr lang="en-US" sz="2600" b="1" dirty="0" smtClean="0">
+                <a:solidFill>
+                  <a:srgbClr val="0F172A"/>
+                </a:solidFill>
+              </a:rPr>
+              <a:t>2. BOTS Dataset</a:t>
             </a:r>
           </a:p>
         </p:txBody>
@@ -908,22 +908,22 @@
           <a:lstStyle/>
           <a:p>
             <a:r>
-              <a:rPr lang="zh-CN" sz="1900" b="0" dirty="0" smtClean="0">
-                <a:solidFill>
-                  <a:srgbClr val="0F172A"/>
-                </a:solidFill>
-              </a:rPr>
-              <a:t>BOTS（Boss of the SOC）是 Splunk 提供的开源安全分析数据集，</a:t>
-            </a:r>
-          </a:p>
-          <a:p>
-            <a:r>
-              <a:rPr lang="zh-CN" sz="1900" b="0" dirty="0" smtClean="0">
-                <a:solidFill>
-                  <a:srgbClr val="0F172A"/>
-                </a:solidFill>
-              </a:rPr>
-              <a:t>适合用来验证攻击溯源、日志关联分析与查询策略。</a:t>
+              <a:rPr lang="en-US" sz="1800" b="0" dirty="0" smtClean="0">
+                <a:solidFill>
+                  <a:srgbClr val="0F172A"/>
+                </a:solidFill>
+              </a:rPr>
+              <a:t>BOTS (Boss of the SOC) is an open security-analysis dataset from Splunk,</a:t>
+            </a:r>
+          </a:p>
+          <a:p>
+            <a:r>
+              <a:rPr lang="en-US" sz="1800" b="0" dirty="0" smtClean="0">
+                <a:solidFill>
+                  <a:srgbClr val="0F172A"/>
+                </a:solidFill>
+              </a:rPr>
+              <a:t>well suited for attack traceback, log correlation analysis, and query-strategy validation.</a:t>
             </a:r>
           </a:p>
         </p:txBody>
@@ -956,42 +956,42 @@
           <a:lstStyle/>
           <a:p>
             <a:r>
-              <a:rPr lang="zh-CN" sz="1700" b="0" dirty="0" smtClean="0">
-                <a:solidFill>
-                  <a:srgbClr val="0F172A"/>
-                </a:solidFill>
-              </a:rPr>
-              <a:t>当前项目中的使用方式</a:t>
-            </a:r>
-          </a:p>
-          <a:p>
-            <a:r>
-              <a:rPr lang="zh-CN" sz="1700" b="0" dirty="0" smtClean="0">
-                <a:solidFill>
-                  <a:srgbClr val="0F172A"/>
-                </a:solidFill>
-              </a:rPr>
-              <a:t>• 默认接入 botsv1，也预留了 botsv2 / botsv3 配置</a:t>
-            </a:r>
-          </a:p>
-          <a:p>
-            <a:r>
-              <a:rPr lang="zh-CN" sz="1700" b="0" dirty="0" smtClean="0">
-                <a:solidFill>
-                  <a:srgbClr val="0F172A"/>
-                </a:solidFill>
-              </a:rPr>
-              <a:t>• 通过 Splunk REST API 执行真实查询，而不是前端假数据</a:t>
-            </a:r>
-          </a:p>
-          <a:p>
-            <a:r>
-              <a:rPr lang="zh-CN" sz="1700" b="0" dirty="0" smtClean="0">
-                <a:solidFill>
-                  <a:srgbClr val="0F172A"/>
-                </a:solidFill>
-              </a:rPr>
-              <a:t>• 便于验证多轮调查流程在不同日志类型上的泛化能力</a:t>
+              <a:rPr lang="en-US" sz="1650" b="0" dirty="0" smtClean="0">
+                <a:solidFill>
+                  <a:srgbClr val="0F172A"/>
+                </a:solidFill>
+              </a:rPr>
+              <a:t>How we use it in this project</a:t>
+            </a:r>
+          </a:p>
+          <a:p>
+            <a:r>
+              <a:rPr lang="en-US" sz="1650" b="0" dirty="0" smtClean="0">
+                <a:solidFill>
+                  <a:srgbClr val="0F172A"/>
+                </a:solidFill>
+              </a:rPr>
+              <a:t>• botsv1 is the default dataset, with botsv2 / botsv3 reserved as well</a:t>
+            </a:r>
+          </a:p>
+          <a:p>
+            <a:r>
+              <a:rPr lang="en-US" sz="1650" b="0" dirty="0" smtClean="0">
+                <a:solidFill>
+                  <a:srgbClr val="0F172A"/>
+                </a:solidFill>
+              </a:rPr>
+              <a:t>• Queries run through the Splunk REST API rather than front-end mock data</a:t>
+            </a:r>
+          </a:p>
+          <a:p>
+            <a:r>
+              <a:rPr lang="en-US" sz="1650" b="0" dirty="0" smtClean="0">
+                <a:solidFill>
+                  <a:srgbClr val="0F172A"/>
+                </a:solidFill>
+              </a:rPr>
+              <a:t>• It helps validate whether the multi-round workflow generalizes across log types</a:t>
             </a:r>
           </a:p>
         </p:txBody>
@@ -1024,17 +1024,17 @@
           <a:lstStyle/>
           <a:p>
             <a:r>
-              <a:rPr lang="zh-CN" sz="1650" b="0" dirty="0" smtClean="0">
-                <a:solidFill>
-                  <a:srgbClr val="0F172A"/>
-                </a:solidFill>
-              </a:rPr>
-              <a:t>botsv1 典型日志类型</a:t>
-            </a:r>
-          </a:p>
-          <a:p>
-            <a:r>
-              <a:rPr lang="zh-CN" sz="1650" b="0" dirty="0" smtClean="0">
+              <a:rPr lang="en-US" sz="1600" b="0" dirty="0" smtClean="0">
+                <a:solidFill>
+                  <a:srgbClr val="0F172A"/>
+                </a:solidFill>
+              </a:rPr>
+              <a:t>Typical botsv1 log types</a:t>
+            </a:r>
+          </a:p>
+          <a:p>
+            <a:r>
+              <a:rPr lang="en-US" sz="1600" b="0" dirty="0" smtClean="0">
                 <a:solidFill>
                   <a:srgbClr val="0F172A"/>
                 </a:solidFill>
@@ -1044,7 +1044,7 @@
           </a:p>
           <a:p>
             <a:r>
-              <a:rPr lang="zh-CN" sz="1650" b="0" dirty="0" smtClean="0">
+              <a:rPr lang="en-US" sz="1600" b="0" dirty="0" smtClean="0">
                 <a:solidFill>
                   <a:srgbClr val="0F172A"/>
                 </a:solidFill>
@@ -1054,7 +1054,7 @@
           </a:p>
           <a:p>
             <a:r>
-              <a:rPr lang="zh-CN" sz="1650" b="0" dirty="0" smtClean="0">
+              <a:rPr lang="en-US" sz="1600" b="0" dirty="0" smtClean="0">
                 <a:solidFill>
                   <a:srgbClr val="0F172A"/>
                 </a:solidFill>
@@ -1064,12 +1064,12 @@
           </a:p>
           <a:p>
             <a:r>
-              <a:rPr lang="zh-CN" sz="1650" b="0" dirty="0" smtClean="0">
-                <a:solidFill>
-                  <a:srgbClr val="0F172A"/>
-                </a:solidFill>
-              </a:rPr>
-              <a:t>• 注册表与主机行为日志</a:t>
+              <a:rPr lang="en-US" sz="1600" b="0" dirty="0" smtClean="0">
+                <a:solidFill>
+                  <a:srgbClr val="0F172A"/>
+                </a:solidFill>
+              </a:rPr>
+              <a:t>• Registry and host-behavior logs</a:t>
             </a:r>
           </a:p>
         </p:txBody>
@@ -1102,42 +1102,42 @@
           <a:lstStyle/>
           <a:p>
             <a:r>
-              <a:rPr lang="zh-CN" sz="1650" b="0" dirty="0" smtClean="0">
-                <a:solidFill>
-                  <a:srgbClr val="0F172A"/>
-                </a:solidFill>
-              </a:rPr>
-              <a:t>为什么适合当前阶段</a:t>
-            </a:r>
-          </a:p>
-          <a:p>
-            <a:r>
-              <a:rPr lang="zh-CN" sz="1650" b="0" dirty="0" smtClean="0">
-                <a:solidFill>
-                  <a:srgbClr val="0F172A"/>
-                </a:solidFill>
-              </a:rPr>
-              <a:t>• 数据公开，便于复现实验</a:t>
-            </a:r>
-          </a:p>
-          <a:p>
-            <a:r>
-              <a:rPr lang="zh-CN" sz="1650" b="0" dirty="0" smtClean="0">
-                <a:solidFill>
-                  <a:srgbClr val="0F172A"/>
-                </a:solidFill>
-              </a:rPr>
-              <a:t>• 既有网络流量，也有主机日志</a:t>
-            </a:r>
-          </a:p>
-          <a:p>
-            <a:r>
-              <a:rPr lang="zh-CN" sz="1650" b="0" dirty="0" smtClean="0">
-                <a:solidFill>
-                  <a:srgbClr val="0F172A"/>
-                </a:solidFill>
-              </a:rPr>
-              <a:t>• 能支撑从告警到证据链的完整验证</a:t>
+              <a:rPr lang="en-US" sz="1600" b="0" dirty="0" smtClean="0">
+                <a:solidFill>
+                  <a:srgbClr val="0F172A"/>
+                </a:solidFill>
+              </a:rPr>
+              <a:t>Why it fits the current stage</a:t>
+            </a:r>
+          </a:p>
+          <a:p>
+            <a:r>
+              <a:rPr lang="en-US" sz="1600" b="0" dirty="0" smtClean="0">
+                <a:solidFill>
+                  <a:srgbClr val="0F172A"/>
+                </a:solidFill>
+              </a:rPr>
+              <a:t>• Public data makes experiments easy to reproduce</a:t>
+            </a:r>
+          </a:p>
+          <a:p>
+            <a:r>
+              <a:rPr lang="en-US" sz="1600" b="0" dirty="0" smtClean="0">
+                <a:solidFill>
+                  <a:srgbClr val="0F172A"/>
+                </a:solidFill>
+              </a:rPr>
+              <a:t>• Includes both network traffic and host logs</a:t>
+            </a:r>
+          </a:p>
+          <a:p>
+            <a:r>
+              <a:rPr lang="en-US" sz="1600" b="0" dirty="0" smtClean="0">
+                <a:solidFill>
+                  <a:srgbClr val="0F172A"/>
+                </a:solidFill>
+              </a:rPr>
+              <a:t>• Supports full validation from alert to evidence chain</a:t>
             </a:r>
           </a:p>
         </p:txBody>
@@ -1199,12 +1199,12 @@
           <a:lstStyle/>
           <a:p>
             <a:r>
-              <a:rPr lang="zh-CN" sz="2600" b="1" dirty="0" smtClean="0">
-                <a:solidFill>
-                  <a:srgbClr val="0F172A"/>
-                </a:solidFill>
-              </a:rPr>
-              <a:t>3. 前后端技术栈</a:t>
+              <a:rPr lang="en-US" sz="2600" b="1" dirty="0" smtClean="0">
+                <a:solidFill>
+                  <a:srgbClr val="0F172A"/>
+                </a:solidFill>
+              </a:rPr>
+              <a:t>3. Frontend and Backend Stack</a:t>
             </a:r>
           </a:p>
         </p:txBody>
@@ -1235,17 +1235,17 @@
           <a:lstStyle/>
           <a:p>
             <a:r>
-              <a:rPr lang="zh-CN" sz="1750" b="0" dirty="0" smtClean="0">
+              <a:rPr lang="en-US" sz="1700" b="0" dirty="0" smtClean="0">
                 <a:solidFill>
                   <a:srgbClr val="FFFFFF"/>
                 </a:solidFill>
               </a:rPr>
-              <a:t>后端</a:t>
-            </a:r>
-          </a:p>
-          <a:p>
-            <a:r>
-              <a:rPr lang="zh-CN" sz="1750" b="0" dirty="0" smtClean="0">
+              <a:t>Backend</a:t>
+            </a:r>
+          </a:p>
+          <a:p>
+            <a:r>
+              <a:rPr lang="en-US" sz="1700" b="0" dirty="0" smtClean="0">
                 <a:solidFill>
                   <a:srgbClr val="FFFFFF"/>
                 </a:solidFill>
@@ -1255,7 +1255,7 @@
           </a:p>
           <a:p>
             <a:r>
-              <a:rPr lang="zh-CN" sz="1750" b="0" dirty="0" smtClean="0">
+              <a:rPr lang="en-US" sz="1700" b="0" dirty="0" smtClean="0">
                 <a:solidFill>
                   <a:srgbClr val="FFFFFF"/>
                 </a:solidFill>
@@ -1265,32 +1265,32 @@
           </a:p>
           <a:p>
             <a:r>
-              <a:rPr lang="zh-CN" sz="1750" b="0" dirty="0" smtClean="0">
+              <a:rPr lang="en-US" sz="1700" b="0" dirty="0" smtClean="0">
                 <a:solidFill>
                   <a:srgbClr val="FFFFFF"/>
                 </a:solidFill>
               </a:rPr>
-              <a:t>• SQLite 作为共享状态中心</a:t>
-            </a:r>
-          </a:p>
-          <a:p>
-            <a:r>
-              <a:rPr lang="zh-CN" sz="1750" b="0" dirty="0" smtClean="0">
+              <a:t>• SQLite as the shared state hub</a:t>
+            </a:r>
+          </a:p>
+          <a:p>
+            <a:r>
+              <a:rPr lang="en-US" sz="1700" b="0" dirty="0" smtClean="0">
                 <a:solidFill>
                   <a:srgbClr val="FFFFFF"/>
                 </a:solidFill>
               </a:rPr>
-              <a:t>• OpenAI 兼容 LLM 接口封装</a:t>
-            </a:r>
-          </a:p>
-          <a:p>
-            <a:r>
-              <a:rPr lang="zh-CN" sz="1750" b="0" dirty="0" smtClean="0">
+              <a:t>• OpenAI-compatible LLM integration</a:t>
+            </a:r>
+          </a:p>
+          <a:p>
+            <a:r>
+              <a:rPr lang="en-US" sz="1700" b="0" dirty="0" smtClean="0">
                 <a:solidFill>
                   <a:srgbClr val="FFFFFF"/>
                 </a:solidFill>
               </a:rPr>
-              <a:t>• Splunk / VirusTotal / IPInfo 工具接入</a:t>
+              <a:t>• Splunk / VirusTotal / IPInfo tool integration</a:t>
             </a:r>
           </a:p>
         </p:txBody>
@@ -1321,27 +1321,27 @@
           <a:lstStyle/>
           <a:p>
             <a:r>
-              <a:rPr lang="zh-CN" sz="1750" b="0" dirty="0" smtClean="0">
+              <a:rPr lang="en-US" sz="1700" b="0" dirty="0" smtClean="0">
                 <a:solidFill>
                   <a:srgbClr val="FFFFFF"/>
                 </a:solidFill>
               </a:rPr>
-              <a:t>前端</a:t>
-            </a:r>
-          </a:p>
-          <a:p>
-            <a:r>
-              <a:rPr lang="zh-CN" sz="1750" b="0" dirty="0" smtClean="0">
+              <a:t>Frontend</a:t>
+            </a:r>
+          </a:p>
+          <a:p>
+            <a:r>
+              <a:rPr lang="en-US" sz="1700" b="0" dirty="0" smtClean="0">
                 <a:solidFill>
                   <a:srgbClr val="FFFFFF"/>
                 </a:solidFill>
               </a:rPr>
-              <a:t>• Jinja2 模板页面</a:t>
-            </a:r>
-          </a:p>
-          <a:p>
-            <a:r>
-              <a:rPr lang="zh-CN" sz="1750" b="0" dirty="0" smtClean="0">
+              <a:t>• Jinja2 template pages</a:t>
+            </a:r>
+          </a:p>
+          <a:p>
+            <a:r>
+              <a:rPr lang="en-US" sz="1700" b="0" dirty="0" smtClean="0">
                 <a:solidFill>
                   <a:srgbClr val="FFFFFF"/>
                 </a:solidFill>
@@ -1351,32 +1351,32 @@
           </a:p>
           <a:p>
             <a:r>
-              <a:rPr lang="zh-CN" sz="1750" b="0" dirty="0" smtClean="0">
+              <a:rPr lang="en-US" sz="1700" b="0" dirty="0" smtClean="0">
                 <a:solidFill>
                   <a:srgbClr val="FFFFFF"/>
                 </a:solidFill>
               </a:rPr>
-              <a:t>• 原生 JavaScript</a:t>
-            </a:r>
-          </a:p>
-          <a:p>
-            <a:r>
-              <a:rPr lang="zh-CN" sz="1750" b="0" dirty="0" smtClean="0">
+              <a:t>• Vanilla JavaScript</a:t>
+            </a:r>
+          </a:p>
+          <a:p>
+            <a:r>
+              <a:rPr lang="en-US" sz="1700" b="0" dirty="0" smtClean="0">
                 <a:solidFill>
                   <a:srgbClr val="FFFFFF"/>
                 </a:solidFill>
               </a:rPr>
-              <a:t>• Socket.IO 实时消息推送</a:t>
-            </a:r>
-          </a:p>
-          <a:p>
-            <a:r>
-              <a:rPr lang="zh-CN" sz="1750" b="0" dirty="0" smtClean="0">
+              <a:t>• Socket.IO real-time message updates</a:t>
+            </a:r>
+          </a:p>
+          <a:p>
+            <a:r>
+              <a:rPr lang="en-US" sz="1700" b="0" dirty="0" smtClean="0">
                 <a:solidFill>
                   <a:srgbClr val="FFFFFF"/>
                 </a:solidFill>
               </a:rPr>
-              <a:t>• 首页 + War Room 双页面结构</a:t>
+              <a:t>• Home page + War Room structure</a:t>
             </a:r>
           </a:p>
         </p:txBody>
@@ -1409,27 +1409,27 @@
           <a:lstStyle/>
           <a:p>
             <a:r>
-              <a:rPr lang="zh-CN" sz="1700" b="1" dirty="0" smtClean="0">
-                <a:solidFill>
-                  <a:srgbClr val="0F172A"/>
-                </a:solidFill>
-              </a:rPr>
-              <a:t>运行结构</a:t>
-            </a:r>
-          </a:p>
-          <a:p>
-            <a:r>
-              <a:rPr lang="zh-CN" sz="1700" b="1" dirty="0" smtClean="0">
-                <a:solidFill>
-                  <a:srgbClr val="0F172A"/>
-                </a:solidFill>
-              </a:rPr>
-              <a:t>Web 层</a:t>
-            </a:r>
-          </a:p>
-          <a:p>
-            <a:r>
-              <a:rPr lang="zh-CN" sz="1700" b="1" dirty="0" smtClean="0">
+              <a:rPr lang="en-US" sz="1650" b="1" dirty="0" smtClean="0">
+                <a:solidFill>
+                  <a:srgbClr val="0F172A"/>
+                </a:solidFill>
+              </a:rPr>
+              <a:t>Runtime structure</a:t>
+            </a:r>
+          </a:p>
+          <a:p>
+            <a:r>
+              <a:rPr lang="en-US" sz="1650" b="1" dirty="0" smtClean="0">
+                <a:solidFill>
+                  <a:srgbClr val="0F172A"/>
+                </a:solidFill>
+              </a:rPr>
+              <a:t>Web layer</a:t>
+            </a:r>
+          </a:p>
+          <a:p>
+            <a:r>
+              <a:rPr lang="en-US" sz="1650" b="1" dirty="0" smtClean="0">
                 <a:solidFill>
                   <a:srgbClr val="0F172A"/>
                 </a:solidFill>
@@ -1439,7 +1439,7 @@
           </a:p>
           <a:p>
             <a:r>
-              <a:rPr lang="zh-CN" sz="1700" b="1" dirty="0" smtClean="0">
+              <a:rPr lang="en-US" sz="1650" b="1" dirty="0" smtClean="0">
                 <a:solidFill>
                   <a:srgbClr val="0F172A"/>
                 </a:solidFill>
@@ -1449,7 +1449,7 @@
           </a:p>
           <a:p>
             <a:r>
-              <a:rPr lang="zh-CN" sz="1700" b="1" dirty="0" smtClean="0">
+              <a:rPr lang="en-US" sz="1650" b="1" dirty="0" smtClean="0">
                 <a:solidFill>
                   <a:srgbClr val="0F172A"/>
                 </a:solidFill>
@@ -1459,7 +1459,7 @@
           </a:p>
           <a:p>
             <a:r>
-              <a:rPr lang="zh-CN" sz="1700" b="1" dirty="0" smtClean="0">
+              <a:rPr lang="en-US" sz="1650" b="1" dirty="0" smtClean="0">
                 <a:solidFill>
                   <a:srgbClr val="0F172A"/>
                 </a:solidFill>
@@ -1497,12 +1497,12 @@
           <a:lstStyle/>
           <a:p>
             <a:r>
-              <a:rPr lang="zh-CN" sz="1750" b="0" dirty="0" smtClean="0">
+              <a:rPr lang="en-US" sz="1600" b="0" dirty="0" smtClean="0">
                 <a:solidFill>
                   <a:srgbClr val="334155"/>
                 </a:solidFill>
               </a:rPr>
-              <a:t>特点：当前系统已经不是静态演示页面，而是前后端联动、消费真实状态数据的可运行原型。</a:t>
+              <a:t>The current system is not a static demo page. It is a runnable prototype where the frontend and backend consume real runtime state together.</a:t>
             </a:r>
           </a:p>
         </p:txBody>
@@ -1564,12 +1564,12 @@
           <a:lstStyle/>
           <a:p>
             <a:r>
-              <a:rPr lang="zh-CN" sz="2600" b="1" dirty="0" smtClean="0">
-                <a:solidFill>
-                  <a:srgbClr val="0F172A"/>
-                </a:solidFill>
-              </a:rPr>
-              <a:t>4. 界面展示</a:t>
+              <a:rPr lang="en-US" sz="2600" b="1" dirty="0" smtClean="0">
+                <a:solidFill>
+                  <a:srgbClr val="0F172A"/>
+                </a:solidFill>
+              </a:rPr>
+              <a:t>4. UI Preview and Next Steps</a:t>
             </a:r>
           </a:p>
         </p:txBody>
@@ -1583,7 +1583,7 @@
         <p:spPr>
           <a:xfrm>
             <a:off x="731520" y="1325880"/>
-            <a:ext cx="5303520" cy="4389120"/>
+            <a:ext cx="3657600" cy="3474720"/>
           </a:xfrm>
           <a:prstGeom prst="rect">
             <a:avLst/>
@@ -1602,7 +1602,7 @@
           <a:lstStyle/>
           <a:p>
             <a:r>
-              <a:rPr lang="zh-CN" sz="2400" b="0" dirty="0" smtClean="0">
+              <a:rPr lang="en-US" sz="2400" b="0" dirty="0" smtClean="0">
                 <a:solidFill>
                   <a:srgbClr val="1F2937"/>
                 </a:solidFill>
@@ -1621,7 +1621,7 @@
         <p:spPr>
           <a:xfrm>
             <a:off x="914400" y="1554480"/>
-            <a:ext cx="4937760" cy="411480"/>
+            <a:ext cx="3291840" cy="411480"/>
           </a:xfrm>
           <a:prstGeom prst="rect">
             <a:avLst/>
@@ -1638,7 +1638,7 @@
           <a:lstStyle/>
           <a:p>
             <a:r>
-              <a:rPr lang="zh-CN" sz="1500" b="1" dirty="0" smtClean="0">
+              <a:rPr lang="en-US" sz="1500" b="1" dirty="0" smtClean="0">
                 <a:solidFill>
                   <a:srgbClr val="FFFFFF"/>
                 </a:solidFill>
@@ -1657,7 +1657,7 @@
         <p:spPr>
           <a:xfrm>
             <a:off x="960120" y="2148840"/>
-            <a:ext cx="1828800" cy="2560320"/>
+            <a:ext cx="1280160" cy="1920240"/>
           </a:xfrm>
           <a:prstGeom prst="rect">
             <a:avLst/>
@@ -1676,12 +1676,12 @@
           <a:lstStyle/>
           <a:p>
             <a:r>
-              <a:rPr lang="zh-CN" sz="1800" b="1" dirty="0" smtClean="0">
-                <a:solidFill>
-                  <a:srgbClr val="0F172A"/>
-                </a:solidFill>
-              </a:rPr>
-              <a:t>创建事件表单</a:t>
+              <a:rPr lang="en-US" sz="1700" b="1" dirty="0" smtClean="0">
+                <a:solidFill>
+                  <a:srgbClr val="0F172A"/>
+                </a:solidFill>
+              </a:rPr>
+              <a:t>Event Form</a:t>
             </a:r>
           </a:p>
         </p:txBody>
@@ -1694,8 +1694,8 @@
         </p:nvSpPr>
         <p:spPr>
           <a:xfrm>
-            <a:off x="3017520" y="2148840"/>
-            <a:ext cx="2651760" cy="2560320"/>
+            <a:off x="2423160" y="2148840"/>
+            <a:ext cx="1737360" cy="1920240"/>
           </a:xfrm>
           <a:prstGeom prst="rect">
             <a:avLst/>
@@ -1714,17 +1714,17 @@
           <a:lstStyle/>
           <a:p>
             <a:r>
-              <a:rPr lang="zh-CN" sz="1600" b="0" dirty="0" smtClean="0">
-                <a:solidFill>
-                  <a:srgbClr val="0F172A"/>
-                </a:solidFill>
-              </a:rPr>
-              <a:t>事件列表</a:t>
-            </a:r>
-          </a:p>
-          <a:p>
-            <a:r>
-              <a:rPr lang="zh-CN" sz="1600" b="0" dirty="0" smtClean="0">
+              <a:rPr lang="en-US" sz="1450" b="0" dirty="0" smtClean="0">
+                <a:solidFill>
+                  <a:srgbClr val="0F172A"/>
+                </a:solidFill>
+              </a:rPr>
+              <a:t>Event List</a:t>
+            </a:r>
+          </a:p>
+          <a:p>
+            <a:r>
+              <a:rPr lang="en-US" sz="1450" b="0" dirty="0" smtClean="0">
                 <a:solidFill>
                   <a:srgbClr val="0F172A"/>
                 </a:solidFill>
@@ -1734,22 +1734,22 @@
           </a:p>
           <a:p>
             <a:r>
-              <a:rPr lang="zh-CN" sz="1600" b="0" dirty="0" smtClean="0">
-                <a:solidFill>
-                  <a:srgbClr val="0F172A"/>
-                </a:solidFill>
-              </a:rPr>
-              <a:t>按状态与时间查看</a:t>
-            </a:r>
-          </a:p>
-          <a:p>
-            <a:r>
-              <a:rPr lang="zh-CN" sz="1600" b="0" dirty="0" smtClean="0">
-                <a:solidFill>
-                  <a:srgbClr val="0F172A"/>
-                </a:solidFill>
-              </a:rPr>
-              <a:t>已创建的调查任务</a:t>
+              <a:rPr lang="en-US" sz="1450" b="0" dirty="0" smtClean="0">
+                <a:solidFill>
+                  <a:srgbClr val="0F172A"/>
+                </a:solidFill>
+              </a:rPr>
+              <a:t>View created investigations</a:t>
+            </a:r>
+          </a:p>
+          <a:p>
+            <a:r>
+              <a:rPr lang="en-US" sz="1450" b="0" dirty="0" smtClean="0">
+                <a:solidFill>
+                  <a:srgbClr val="0F172A"/>
+                </a:solidFill>
+              </a:rPr>
+              <a:t>by status and time</a:t>
             </a:r>
           </a:p>
         </p:txBody>
@@ -1762,8 +1762,8 @@
         </p:nvSpPr>
         <p:spPr>
           <a:xfrm>
-            <a:off x="868680" y="5074920"/>
-            <a:ext cx="4983480" cy="502920"/>
+            <a:off x="868680" y="4983480"/>
+            <a:ext cx="3383280" cy="640080"/>
           </a:xfrm>
           <a:prstGeom prst="rect">
             <a:avLst/>
@@ -1778,42 +1778,42 @@
           <a:lstStyle/>
           <a:p>
             <a:r>
-              <a:rPr lang="zh-CN" sz="1450" b="0" dirty="0" smtClean="0">
+              <a:rPr lang="en-US" sz="1350" b="0" dirty="0" smtClean="0">
                 <a:solidFill>
                   <a:srgbClr val="334155"/>
                 </a:solidFill>
               </a:rPr>
-              <a:t>首页</a:t>
-            </a:r>
-          </a:p>
-          <a:p>
-            <a:r>
-              <a:rPr lang="zh-CN" sz="1450" b="0" dirty="0" smtClean="0">
+              <a:t>Home page</a:t>
+            </a:r>
+          </a:p>
+          <a:p>
+            <a:r>
+              <a:rPr lang="en-US" sz="1350" b="0" dirty="0" smtClean="0">
                 <a:solidFill>
                   <a:srgbClr val="334155"/>
                 </a:solidFill>
               </a:rPr>
-              <a:t>• 创建安全事件</a:t>
-            </a:r>
-          </a:p>
-          <a:p>
-            <a:r>
-              <a:rPr lang="zh-CN" sz="1450" b="0" dirty="0" smtClean="0">
+              <a:t>• Create security events</a:t>
+            </a:r>
+          </a:p>
+          <a:p>
+            <a:r>
+              <a:rPr lang="en-US" sz="1350" b="0" dirty="0" smtClean="0">
                 <a:solidFill>
                   <a:srgbClr val="334155"/>
                 </a:solidFill>
               </a:rPr>
-              <a:t>• 查看事件列表</a:t>
-            </a:r>
-          </a:p>
-          <a:p>
-            <a:r>
-              <a:rPr lang="zh-CN" sz="1450" b="0" dirty="0" smtClean="0">
+              <a:t>• View the event list</a:t>
+            </a:r>
+          </a:p>
+          <a:p>
+            <a:r>
+              <a:rPr lang="en-US" sz="1350" b="0" dirty="0" smtClean="0">
                 <a:solidFill>
                   <a:srgbClr val="334155"/>
                 </a:solidFill>
               </a:rPr>
-              <a:t>• 进入单事件 war room</a:t>
+              <a:t>• Enter a single-event war room</a:t>
             </a:r>
           </a:p>
         </p:txBody>
@@ -1826,8 +1826,8 @@
         </p:nvSpPr>
         <p:spPr>
           <a:xfrm>
-            <a:off x="6217920" y="1325880"/>
-            <a:ext cx="5257800" cy="4389120"/>
+            <a:off x="4709160" y="1325880"/>
+            <a:ext cx="3840480" cy="3474720"/>
           </a:xfrm>
           <a:prstGeom prst="rect">
             <a:avLst/>
@@ -1846,7 +1846,7 @@
           <a:lstStyle/>
           <a:p>
             <a:r>
-              <a:rPr lang="zh-CN" sz="2400" b="0" dirty="0" smtClean="0">
+              <a:rPr lang="en-US" sz="2400" b="0" dirty="0" smtClean="0">
                 <a:solidFill>
                   <a:srgbClr val="1F2937"/>
                 </a:solidFill>
@@ -1864,8 +1864,8 @@
         </p:nvSpPr>
         <p:spPr>
           <a:xfrm>
-            <a:off x="6400800" y="1554480"/>
-            <a:ext cx="4892040" cy="411480"/>
+            <a:off x="4892040" y="1554480"/>
+            <a:ext cx="3474720" cy="411480"/>
           </a:xfrm>
           <a:prstGeom prst="rect">
             <a:avLst/>
@@ -1882,7 +1882,7 @@
           <a:lstStyle/>
           <a:p>
             <a:r>
-              <a:rPr lang="zh-CN" sz="1500" b="1" dirty="0" smtClean="0">
+              <a:rPr lang="en-US" sz="1500" b="1" dirty="0" smtClean="0">
                 <a:solidFill>
                   <a:srgbClr val="FFFFFF"/>
                 </a:solidFill>
@@ -1900,8 +1900,8 @@
         </p:nvSpPr>
         <p:spPr>
           <a:xfrm>
-            <a:off x="6446520" y="2148840"/>
-            <a:ext cx="3246120" cy="2651760"/>
+            <a:off x="4937760" y="2148840"/>
+            <a:ext cx="2331720" cy="2011680"/>
           </a:xfrm>
           <a:prstGeom prst="rect">
             <a:avLst/>
@@ -1920,17 +1920,17 @@
           <a:lstStyle/>
           <a:p>
             <a:r>
-              <a:rPr lang="zh-CN" sz="1600" b="0" dirty="0" smtClean="0">
+              <a:rPr lang="en-US" sz="1450" b="0" dirty="0" smtClean="0">
                 <a:solidFill>
                   <a:srgbClr val="E2E8F0"/>
                 </a:solidFill>
               </a:rPr>
-              <a:t>消息流</a:t>
-            </a:r>
-          </a:p>
-          <a:p>
-            <a:r>
-              <a:rPr lang="zh-CN" sz="1600" b="0" dirty="0" smtClean="0">
+              <a:t>Message Stream</a:t>
+            </a:r>
+          </a:p>
+          <a:p>
+            <a:r>
+              <a:rPr lang="en-US" sz="1450" b="0" dirty="0" smtClean="0">
                 <a:solidFill>
                   <a:srgbClr val="E2E8F0"/>
                 </a:solidFill>
@@ -1940,7 +1940,7 @@
           </a:p>
           <a:p>
             <a:r>
-              <a:rPr lang="zh-CN" sz="1600" b="0" dirty="0" smtClean="0">
+              <a:rPr lang="en-US" sz="1450" b="0" dirty="0" smtClean="0">
                 <a:solidFill>
                   <a:srgbClr val="E2E8F0"/>
                 </a:solidFill>
@@ -1950,12 +1950,12 @@
           </a:p>
           <a:p>
             <a:r>
-              <a:rPr lang="zh-CN" sz="1600" b="0" dirty="0" smtClean="0">
+              <a:rPr lang="en-US" sz="1450" b="0" dirty="0" smtClean="0">
                 <a:solidFill>
                   <a:srgbClr val="E2E8F0"/>
                 </a:solidFill>
               </a:rPr>
-              <a:t>Reviewer 的实时协作内容</a:t>
+              <a:t>Reviewer collaboration</a:t>
             </a:r>
           </a:p>
         </p:txBody>
@@ -1968,8 +1968,8 @@
         </p:nvSpPr>
         <p:spPr>
           <a:xfrm>
-            <a:off x="9875520" y="2148840"/>
-            <a:ext cx="1645920" cy="2651760"/>
+            <a:off x="7452360" y="2148840"/>
+            <a:ext cx="914400" cy="2011680"/>
           </a:xfrm>
           <a:prstGeom prst="rect">
             <a:avLst/>
@@ -1988,17 +1988,17 @@
           <a:lstStyle/>
           <a:p>
             <a:r>
-              <a:rPr lang="zh-CN" sz="1500" b="0" dirty="0" smtClean="0">
+              <a:rPr lang="en-US" sz="1350" b="0" dirty="0" smtClean="0">
                 <a:solidFill>
                   <a:srgbClr val="E2E8F0"/>
                 </a:solidFill>
               </a:rPr>
-              <a:t>右侧状态栏</a:t>
-            </a:r>
-          </a:p>
-          <a:p>
-            <a:r>
-              <a:rPr lang="zh-CN" sz="1500" b="0" dirty="0" smtClean="0">
+              <a:t>Status</a:t>
+            </a:r>
+          </a:p>
+          <a:p>
+            <a:r>
+              <a:rPr lang="en-US" sz="1350" b="0" dirty="0" smtClean="0">
                 <a:solidFill>
                   <a:srgbClr val="E2E8F0"/>
                 </a:solidFill>
@@ -2008,42 +2008,42 @@
           </a:p>
           <a:p>
             <a:r>
-              <a:rPr lang="zh-CN" sz="1500" b="0" dirty="0" smtClean="0">
+              <a:rPr lang="en-US" sz="1350" b="0" dirty="0" smtClean="0">
                 <a:solidFill>
                   <a:srgbClr val="E2E8F0"/>
                 </a:solidFill>
               </a:rPr>
-              <a:t>轮次</a:t>
-            </a:r>
-          </a:p>
-          <a:p>
-            <a:r>
-              <a:rPr lang="zh-CN" sz="1500" b="0" dirty="0" smtClean="0">
+              <a:t>Round</a:t>
+            </a:r>
+          </a:p>
+          <a:p>
+            <a:r>
+              <a:rPr lang="en-US" sz="1350" b="0" dirty="0" smtClean="0">
                 <a:solidFill>
                   <a:srgbClr val="E2E8F0"/>
                 </a:solidFill>
               </a:rPr>
-              <a:t>节点数</a:t>
-            </a:r>
-          </a:p>
-          <a:p>
-            <a:r>
-              <a:rPr lang="zh-CN" sz="1500" b="0" dirty="0" smtClean="0">
+              <a:t>Leaves</a:t>
+            </a:r>
+          </a:p>
+          <a:p>
+            <a:r>
+              <a:rPr lang="en-US" sz="1350" b="0" dirty="0" smtClean="0">
                 <a:solidFill>
                   <a:srgbClr val="E2E8F0"/>
                 </a:solidFill>
               </a:rPr>
-              <a:t>执行数</a:t>
-            </a:r>
-          </a:p>
-          <a:p>
-            <a:r>
-              <a:rPr lang="zh-CN" sz="1500" b="0" dirty="0" smtClean="0">
+              <a:t>Execs</a:t>
+            </a:r>
+          </a:p>
+          <a:p>
+            <a:r>
+              <a:rPr lang="en-US" sz="1350" b="0" dirty="0" smtClean="0">
                 <a:solidFill>
                   <a:srgbClr val="E2E8F0"/>
                 </a:solidFill>
               </a:rPr>
-              <a:t>角色状态</a:t>
+              <a:t>Roles</a:t>
             </a:r>
           </a:p>
         </p:txBody>
@@ -2056,8 +2056,8 @@
         </p:nvSpPr>
         <p:spPr>
           <a:xfrm>
-            <a:off x="6355080" y="5074920"/>
-            <a:ext cx="4983480" cy="640080"/>
+            <a:off x="4846320" y="4983480"/>
+            <a:ext cx="3566160" cy="731520"/>
           </a:xfrm>
           <a:prstGeom prst="rect">
             <a:avLst/>
@@ -2072,7 +2072,7 @@
           <a:lstStyle/>
           <a:p>
             <a:r>
-              <a:rPr lang="zh-CN" sz="1450" b="0" dirty="0" smtClean="0">
+              <a:rPr lang="en-US" sz="1300" b="0" dirty="0" smtClean="0">
                 <a:solidFill>
                   <a:srgbClr val="334155"/>
                 </a:solidFill>
@@ -2082,52 +2082,130 @@
           </a:p>
           <a:p>
             <a:r>
-              <a:rPr lang="zh-CN" sz="1450" b="0" dirty="0" smtClean="0">
+              <a:rPr lang="en-US" sz="1300" b="0" dirty="0" smtClean="0">
                 <a:solidFill>
                   <a:srgbClr val="334155"/>
                 </a:solidFill>
               </a:rPr>
-              <a:t>• 事件详情与状态</a:t>
-            </a:r>
-          </a:p>
-          <a:p>
-            <a:r>
-              <a:rPr lang="zh-CN" sz="1450" b="0" dirty="0" smtClean="0">
+              <a:t>• Event details and status</a:t>
+            </a:r>
+          </a:p>
+          <a:p>
+            <a:r>
+              <a:rPr lang="en-US" sz="1300" b="0" dirty="0" smtClean="0">
                 <a:solidFill>
                   <a:srgbClr val="334155"/>
                 </a:solidFill>
               </a:rPr>
-              <a:t>• 三角色消息流</a:t>
-            </a:r>
-          </a:p>
-          <a:p>
-            <a:r>
-              <a:rPr lang="zh-CN" sz="1450" b="0" dirty="0" smtClean="0">
+              <a:t>• Three-role message stream</a:t>
+            </a:r>
+          </a:p>
+          <a:p>
+            <a:r>
+              <a:rPr lang="en-US" sz="1300" b="0" dirty="0" smtClean="0">
                 <a:solidFill>
                   <a:srgbClr val="334155"/>
                 </a:solidFill>
               </a:rPr>
-              <a:t>• TTT 层级结构</a:t>
-            </a:r>
-          </a:p>
-          <a:p>
-            <a:r>
-              <a:rPr lang="zh-CN" sz="1450" b="0" dirty="0" smtClean="0">
+              <a:t>• TTT hierarchy</a:t>
+            </a:r>
+          </a:p>
+          <a:p>
+            <a:r>
+              <a:rPr lang="en-US" sz="1300" b="0" dirty="0" smtClean="0">
                 <a:solidFill>
                   <a:srgbClr val="334155"/>
                 </a:solidFill>
               </a:rPr>
-              <a:t>• 执行记录与轮次复盘</a:t>
-            </a:r>
-          </a:p>
-          <a:p>
-            <a:r>
-              <a:rPr lang="zh-CN" sz="1450" b="0" dirty="0" smtClean="0">
+              <a:t>• Execution records and round reviews</a:t>
+            </a:r>
+          </a:p>
+          <a:p>
+            <a:r>
+              <a:rPr lang="en-US" sz="1300" b="0" dirty="0" smtClean="0">
                 <a:solidFill>
                   <a:srgbClr val="334155"/>
                 </a:solidFill>
               </a:rPr>
-              <a:t>• Socket.IO 实时更新</a:t>
+              <a:t>• Socket.IO real-time updates</a:t>
+            </a:r>
+          </a:p>
+        </p:txBody>
+      </p:sp>
+      <p:sp>
+        <p:nvSpPr>
+          <p:cNvPr id="13" name="NextSteps"/>
+          <p:cNvSpPr txBox="1"/>
+          <p:nvPr/>
+        </p:nvSpPr>
+        <p:spPr>
+          <a:xfrm>
+            <a:off x="8869680" y="1325880"/>
+            <a:ext cx="2468880" cy="4297680"/>
+          </a:xfrm>
+          <a:prstGeom prst="rect">
+            <a:avLst/>
+          </a:prstGeom>
+          <a:solidFill>
+            <a:srgbClr val="FEF3C7"/>
+          </a:solidFill>
+          <a:ln w="12700">
+            <a:solidFill>
+              <a:srgbClr val="FCD34D"/>
+            </a:solidFill>
+          </a:ln>
+        </p:spPr>
+        <p:txBody>
+          <a:bodyPr wrap="square" lIns="91440" tIns="45720" rIns="91440" bIns="45720"/>
+          <a:lstStyle/>
+          <a:p>
+            <a:r>
+              <a:rPr lang="en-US" sz="1450" b="0" dirty="0" smtClean="0">
+                <a:solidFill>
+                  <a:srgbClr val="0F172A"/>
+                </a:solidFill>
+              </a:rPr>
+              <a:t>Next steps</a:t>
+            </a:r>
+          </a:p>
+          <a:p>
+            <a:r>
+              <a:rPr lang="en-US" sz="1450" b="0" dirty="0" smtClean="0">
+                <a:solidFill>
+                  <a:srgbClr val="0F172A"/>
+                </a:solidFill>
+              </a:rPr>
+              <a:t>• Keep testing different alert types on BOTS</a:t>
+            </a:r>
+          </a:p>
+          <a:p>
+            <a:r>
+              <a:rPr lang="en-US" sz="1450" b="0" dirty="0" smtClean="0">
+                <a:solidFill>
+                  <a:srgbClr val="0F172A"/>
+                </a:solidFill>
+              </a:rPr>
+              <a:t>• Improve TTT quality and Splunk query generation</a:t>
+            </a:r>
+          </a:p>
+          <a:p>
+            <a:r>
+              <a:rPr lang="en-US" sz="1450" b="0" dirty="0" smtClean="0">
+                <a:solidFill>
+                  <a:srgbClr val="0F172A"/>
+                </a:solidFill>
+              </a:rPr>
+              <a:t>• Expand callable security tools</a:t>
+            </a:r>
+          </a:p>
+          <a:p>
+            <a:r>
+              <a:rPr lang="en-US" sz="1450" b="0" dirty="0" smtClean="0">
+                <a:solidFill>
+                  <a:srgbClr val="0F172A"/>
+                </a:solidFill>
+              </a:rPr>
+              <a:t>• Add more standardized tests and stronger UI observability</a:t>
             </a:r>
           </a:p>
         </p:txBody>
@@ -2184,12 +2262,12 @@
     <a:fontScheme name="Office">
       <a:majorFont>
         <a:latin typeface="Aptos Display"/>
-        <a:ea typeface="Microsoft YaHei"/>
+        <a:ea typeface="Arial"/>
         <a:cs typeface="Arial"/>
       </a:majorFont>
       <a:minorFont>
         <a:latin typeface="Aptos"/>
-        <a:ea typeface="Microsoft YaHei"/>
+        <a:ea typeface="Arial"/>
         <a:cs typeface="Arial"/>
       </a:minorFont>
     </a:fontScheme>

</xml_diff>